<commit_message>
T2: dependencias de Carlos (#1, #8-#11), manual de marca, slogan en la plantilla y hechos actualizados
Co-Authored-By: Claude Opus 5.5 <noreply@anthropic.com>
Claude-Session: https://claude.ai/code/session_01Kfbf7cfV7pXUcNjjyaPCzV
</commit_message>
<xml_diff>
--- a/04-reformulacion/T2/T2_12_Plantilla-PPT-AndiBite.pptx
+++ b/04-reformulacion/T2/T2_12_Plantilla-PPT-AndiBite.pptx
@@ -113,12 +113,12 @@
   <p:extLst>
     <p:ext uri="{521415D9-36F7-43E2-AB2F-B90AF26B5E84}">
       <p14:sectionLst xmlns:p14="http://schemas.microsoft.com/office/powerpoint/2010/main">
-        <p14:section name="Portada" id="{86400f88-1c6d-a61e-8131-fcb3d5374c25}">
+        <p14:section name="Portada" id="{f31b20d2-339a-1169-9426-e672b23e958e}">
           <p14:sldIdLst>
             <p14:sldId id="256"/>
           </p14:sldIdLst>
         </p14:section>
-        <p14:section name="Análisis situacional" id="{9e179830-4997-61c1-1e3d-61fc1b80ae1a}">
+        <p14:section name="Análisis situacional" id="{12d8082d-3b33-7933-c49e-a0e1aff77ea5}">
           <p14:sldIdLst>
             <p14:sldId id="257"/>
             <p14:sldId id="258"/>
@@ -127,7 +127,7 @@
             <p14:sldId id="261"/>
           </p14:sldIdLst>
         </p14:section>
-        <p14:section name="Cierre" id="{3e31ba9a-eb30-64b1-c2a6-3c0f24b081d5}">
+        <p14:section name="Cierre" id="{d2be1cf5-a655-80f5-f2f7-d3f74a7d9700}">
           <p14:sldIdLst>
             <p14:sldId id="262"/>
           </p14:sldIdLst>
@@ -5679,7 +5679,7 @@
                   <a:schemeClr val="bg2"/>
                 </a:solidFill>
               </a:rPr>
-              <a:t>[Slogan del #11]</a:t>
+              <a:t>Hierro medido. Sabor a brownie.</a:t>
             </a:r>
             <a:endParaRPr lang="en-US" sz="4800" dirty="0"/>
           </a:p>

</xml_diff>

<commit_message>
T2: #14 y #15 (borrador), Word y plantilla PPT más livianos para subir al Drive
Co-Authored-By: Claude Opus 5.5 <noreply@anthropic.com>
Claude-Session: https://claude.ai/code/session_01Kfbf7cfV7pXUcNjjyaPCzV
</commit_message>
<xml_diff>
--- a/04-reformulacion/T2/T2_12_Plantilla-PPT-AndiBite.pptx
+++ b/04-reformulacion/T2/T2_12_Plantilla-PPT-AndiBite.pptx
@@ -113,12 +113,12 @@
   <p:extLst>
     <p:ext uri="{521415D9-36F7-43E2-AB2F-B90AF26B5E84}">
       <p14:sectionLst xmlns:p14="http://schemas.microsoft.com/office/powerpoint/2010/main">
-        <p14:section name="Portada" id="{f31b20d2-339a-1169-9426-e672b23e958e}">
+        <p14:section name="Portada" id="{d798e613-6044-9859-25a7-252fe16b1f8a}">
           <p14:sldIdLst>
             <p14:sldId id="256"/>
           </p14:sldIdLst>
         </p14:section>
-        <p14:section name="Análisis situacional" id="{12d8082d-3b33-7933-c49e-a0e1aff77ea5}">
+        <p14:section name="Análisis situacional" id="{0d2b1cc3-0342-07e0-f998-0a5d50e6dd55}">
           <p14:sldIdLst>
             <p14:sldId id="257"/>
             <p14:sldId id="258"/>
@@ -127,7 +127,7 @@
             <p14:sldId id="261"/>
           </p14:sldIdLst>
         </p14:section>
-        <p14:section name="Cierre" id="{d2be1cf5-a655-80f5-f2f7-d3f74a7d9700}">
+        <p14:section name="Cierre" id="{28423cf0-aefb-2d65-8977-32c79f0349f1}">
           <p14:sldIdLst>
             <p14:sldId id="262"/>
           </p14:sldIdLst>
@@ -2443,7 +2443,7 @@
       </p:sp>
       <p:pic>
         <p:nvPicPr>
-          <p:cNvPr id="7" name="Image 1" descr="/home/user/Desarrollo-y-lanzamiento-de-producto-y-marca/assets/empaque/B1_frente.png">    </p:cNvPr>
+          <p:cNvPr id="7" name="Image 1" descr="img/B1_frente.jpg">    </p:cNvPr>
           <p:cNvPicPr>
             <a:picLocks noChangeAspect="1"/>
           </p:cNvPicPr>
@@ -5723,7 +5723,7 @@
       </p:sp>
       <p:pic>
         <p:nvPicPr>
-          <p:cNvPr id="5" name="Image 0" descr="/home/user/Desarrollo-y-lanzamiento-de-producto-y-marca/assets/empaque/B1_frente.png">    </p:cNvPr>
+          <p:cNvPr id="5" name="Image 0" descr="img/B1_frente.jpg">    </p:cNvPr>
           <p:cNvPicPr>
             <a:picLocks noChangeAspect="1"/>
           </p:cNvPicPr>

</xml_diff>

<commit_message>
T2: imágenes y plantilla PPT más livianas para subir al Drive
Co-Authored-By: Claude Opus 5.5 <noreply@anthropic.com>
Claude-Session: https://claude.ai/code/session_01Kfbf7cfV7pXUcNjjyaPCzV
</commit_message>
<xml_diff>
--- a/04-reformulacion/T2/T2_12_Plantilla-PPT-AndiBite.pptx
+++ b/04-reformulacion/T2/T2_12_Plantilla-PPT-AndiBite.pptx
@@ -113,12 +113,12 @@
   <p:extLst>
     <p:ext uri="{521415D9-36F7-43E2-AB2F-B90AF26B5E84}">
       <p14:sectionLst xmlns:p14="http://schemas.microsoft.com/office/powerpoint/2010/main">
-        <p14:section name="Portada" id="{d798e613-6044-9859-25a7-252fe16b1f8a}">
+        <p14:section name="Portada" id="{76e7bf54-3784-8d63-ca46-752cbc3828b0}">
           <p14:sldIdLst>
             <p14:sldId id="256"/>
           </p14:sldIdLst>
         </p14:section>
-        <p14:section name="Análisis situacional" id="{0d2b1cc3-0342-07e0-f998-0a5d50e6dd55}">
+        <p14:section name="Análisis situacional" id="{9dbf3fa2-d2e6-11b8-dc54-13f6f2b206eb}">
           <p14:sldIdLst>
             <p14:sldId id="257"/>
             <p14:sldId id="258"/>
@@ -127,7 +127,7 @@
             <p14:sldId id="261"/>
           </p14:sldIdLst>
         </p14:section>
-        <p14:section name="Cierre" id="{28423cf0-aefb-2d65-8977-32c79f0349f1}">
+        <p14:section name="Cierre" id="{53459a31-6917-5afc-8ec3-190c1f3017f1}">
           <p14:sldIdLst>
             <p14:sldId id="262"/>
           </p14:sldIdLst>
@@ -2443,7 +2443,7 @@
       </p:sp>
       <p:pic>
         <p:nvPicPr>
-          <p:cNvPr id="7" name="Image 1" descr="img/B1_frente.jpg">    </p:cNvPr>
+          <p:cNvPr id="7" name="Image 1" descr="img/B1_frente_s.jpg">    </p:cNvPr>
           <p:cNvPicPr>
             <a:picLocks noChangeAspect="1"/>
           </p:cNvPicPr>
@@ -5723,7 +5723,7 @@
       </p:sp>
       <p:pic>
         <p:nvPicPr>
-          <p:cNvPr id="5" name="Image 0" descr="img/B1_frente.jpg">    </p:cNvPr>
+          <p:cNvPr id="5" name="Image 0" descr="img/B1_frente_s.jpg">    </p:cNvPr>
           <p:cNvPicPr>
             <a:picLocks noChangeAspect="1"/>
           </p:cNvPicPr>

</xml_diff>